<commit_message>
Add per-student automation script and personal order tracker
- student_config.json: single shared config (student name, college, guide, etc.)
  now used by both generate_report.js and generate_deck.js, instead of separate
  hardcoded CONFIG blocks in each.
- scripts/generate_all.sh: regenerates the report + presentation from
  student_config.json and packages both plus the viva question bank into
  deliverables/<student_name>/ in one command.
- tracker/Student_Order_Tracker.xlsx: two-sheet workbook - an Orders Tracker
  with revenue/balance-due formulas and payment-status auto-calculation, and a
  reusable 13-step Delivery Checklist. Includes build_tracker.py to regenerate
  or customize.
- README.md: points to the full selling workflow.
</commit_message>
<xml_diff>
--- a/presentation/PDF_RAG_Chat_Presentation.pptx
+++ b/presentation/PDF_RAG_Chat_Presentation.pptx
@@ -2093,7 +2093,7 @@
                 <a:ea typeface="Calibri" pitchFamily="34" charset="-122"/>
                 <a:cs typeface="Calibri" pitchFamily="34" charset="-120"/>
               </a:rPr>
-              <a:t>[Mini / Major Project]</a:t>
+              <a:t>[Mini Project]</a:t>
             </a:r>
             <a:endParaRPr lang="en-US" sz="1400" dirty="0"/>
           </a:p>
@@ -2149,7 +2149,7 @@
                 <a:ea typeface="Calibri" pitchFamily="34" charset="-122"/>
                 <a:cs typeface="Calibri" pitchFamily="34" charset="-120"/>
               </a:rPr>
-              <a:t>[College Name]  |  [Academic Year]</a:t>
+              <a:t>[College Name]  |  [2025-2026]</a:t>
             </a:r>
             <a:endParaRPr lang="en-US" sz="1400" dirty="0"/>
           </a:p>

</xml_diff>